<commit_message>
corrected dashboard for seeding(for front end )
</commit_message>
<xml_diff>
--- a/docs/CW2_Second_Submission_Slides.pptx
+++ b/docs/CW2_Second_Submission_Slides.pptx
@@ -17,6 +17,7 @@
     <p:sldId id="265" r:id="rId16"/>
     <p:sldId id="266" r:id="rId17"/>
     <p:sldId id="267" r:id="rId18"/>
+    <p:sldId id="268" r:id="rId19"/>
   </p:sldIdLst>
   <p:sldSz cx="12191695" cy="6858000" type="screen4x3"/>
   <p:notesSz cx="6858000" cy="9144000"/>
@@ -3196,71 +3197,435 @@
               </a:defRPr>
             </a:pPr>
             <a:r>
-              <a:t>9. Client Handover and Maintainability</a:t>
-            </a:r>
-          </a:p>
-        </p:txBody>
-      </p:sp>
-      <p:sp>
-        <p:nvSpPr>
-          <p:cNvPr id="3" name="Content Placeholder 2"/>
-          <p:cNvSpPr>
-            <a:spLocks noGrp="1"/>
-          </p:cNvSpPr>
-          <p:nvPr>
-            <p:ph idx="1"/>
-          </p:nvPr>
-        </p:nvSpPr>
-        <p:spPr/>
-        <p:txBody>
-          <a:bodyPr/>
+              <a:t>8. Testing and Quality Evidence</a:t>
+            </a:r>
+          </a:p>
+        </p:txBody>
+      </p:sp>
+      <p:graphicFrame>
+        <p:nvGraphicFramePr>
+          <p:cNvPr id="3" name="Table 2"/>
+          <p:cNvGraphicFramePr>
+            <a:graphicFrameLocks noGrp="1"/>
+          </p:cNvGraphicFramePr>
+          <p:nvPr/>
+        </p:nvGraphicFramePr>
+        <p:xfrm>
+          <a:off x="365760" y="1280160"/>
+          <a:ext cx="11430000" cy="4389120"/>
+        </p:xfrm>
+        <a:graphic>
+          <a:graphicData uri="http://schemas.openxmlformats.org/drawingml/2006/table">
+            <a:tbl>
+              <a:tblPr firstRow="1" bandRow="1">
+                <a:tableStyleId>{5C22544A-7EE6-4342-B048-85BDC9FD1C3A}</a:tableStyleId>
+              </a:tblPr>
+              <a:tblGrid>
+                <a:gridCol w="3810000"/>
+                <a:gridCol w="3810000"/>
+                <a:gridCol w="3810000"/>
+              </a:tblGrid>
+              <a:tr h="731520">
+                <a:tc>
+                  <a:txBody>
+                    <a:bodyPr/>
+                    <a:lstStyle/>
+                    <a:p>
+                      <a:pPr>
+                        <a:defRPr b="1" sz="1400">
+                          <a:solidFill>
+                            <a:srgbClr val="FFFFFF"/>
+                          </a:solidFill>
+                        </a:defRPr>
+                      </a:pPr>
+                      <a:r>
+                        <a:t>Area</a:t>
+                      </a:r>
+                    </a:p>
+                  </a:txBody>
+                  <a:tcPr>
+                    <a:solidFill>
+                      <a:srgbClr val="2563EB"/>
+                    </a:solidFill>
+                  </a:tcPr>
+                </a:tc>
+                <a:tc>
+                  <a:txBody>
+                    <a:bodyPr/>
+                    <a:lstStyle/>
+                    <a:p>
+                      <a:pPr>
+                        <a:defRPr b="1" sz="1400">
+                          <a:solidFill>
+                            <a:srgbClr val="FFFFFF"/>
+                          </a:solidFill>
+                        </a:defRPr>
+                      </a:pPr>
+                      <a:r>
+                        <a:t>Automated coverage</a:t>
+                      </a:r>
+                    </a:p>
+                  </a:txBody>
+                  <a:tcPr>
+                    <a:solidFill>
+                      <a:srgbClr val="2563EB"/>
+                    </a:solidFill>
+                  </a:tcPr>
+                </a:tc>
+                <a:tc>
+                  <a:txBody>
+                    <a:bodyPr/>
+                    <a:lstStyle/>
+                    <a:p>
+                      <a:pPr>
+                        <a:defRPr b="1" sz="1400">
+                          <a:solidFill>
+                            <a:srgbClr val="FFFFFF"/>
+                          </a:solidFill>
+                        </a:defRPr>
+                      </a:pPr>
+                      <a:r>
+                        <a:t>Current evidence</a:t>
+                      </a:r>
+                    </a:p>
+                  </a:txBody>
+                  <a:tcPr>
+                    <a:solidFill>
+                      <a:srgbClr val="2563EB"/>
+                    </a:solidFill>
+                  </a:tcPr>
+                </a:tc>
+              </a:tr>
+              <a:tr h="731520">
+                <a:tc>
+                  <a:txBody>
+                    <a:bodyPr/>
+                    <a:lstStyle/>
+                    <a:p>
+                      <a:pPr>
+                        <a:defRPr sz="1300">
+                          <a:solidFill>
+                            <a:srgbClr val="1E293B"/>
+                          </a:solidFill>
+                        </a:defRPr>
+                      </a:pPr>
+                      <a:r>
+                        <a:t>Telemetry validation</a:t>
+                      </a:r>
+                    </a:p>
+                  </a:txBody>
+                  <a:tcPr/>
+                </a:tc>
+                <a:tc>
+                  <a:txBody>
+                    <a:bodyPr/>
+                    <a:lstStyle/>
+                    <a:p>
+                      <a:pPr>
+                        <a:defRPr sz="1300">
+                          <a:solidFill>
+                            <a:srgbClr val="1E293B"/>
+                          </a:solidFill>
+                        </a:defRPr>
+                      </a:pPr>
+                      <a:r>
+                        <a:t>Unit tests</a:t>
+                      </a:r>
+                    </a:p>
+                  </a:txBody>
+                  <a:tcPr/>
+                </a:tc>
+                <a:tc>
+                  <a:txBody>
+                    <a:bodyPr/>
+                    <a:lstStyle/>
+                    <a:p>
+                      <a:pPr>
+                        <a:defRPr sz="1300">
+                          <a:solidFill>
+                            <a:srgbClr val="1E293B"/>
+                          </a:solidFill>
+                        </a:defRPr>
+                      </a:pPr>
+                      <a:r>
+                        <a:t>Event required fields and types validated</a:t>
+                      </a:r>
+                    </a:p>
+                  </a:txBody>
+                  <a:tcPr/>
+                </a:tc>
+              </a:tr>
+              <a:tr h="731520">
+                <a:tc>
+                  <a:txBody>
+                    <a:bodyPr/>
+                    <a:lstStyle/>
+                    <a:p>
+                      <a:pPr>
+                        <a:defRPr sz="1300">
+                          <a:solidFill>
+                            <a:srgbClr val="1E293B"/>
+                          </a:solidFill>
+                        </a:defRPr>
+                      </a:pPr>
+                      <a:r>
+                        <a:t>Data ingestion/storage</a:t>
+                      </a:r>
+                    </a:p>
+                  </a:txBody>
+                  <a:tcPr/>
+                </a:tc>
+                <a:tc>
+                  <a:txBody>
+                    <a:bodyPr/>
+                    <a:lstStyle/>
+                    <a:p>
+                      <a:pPr>
+                        <a:defRPr sz="1300">
+                          <a:solidFill>
+                            <a:srgbClr val="1E293B"/>
+                          </a:solidFill>
+                        </a:defRPr>
+                      </a:pPr>
+                      <a:r>
+                        <a:t>Integration tests</a:t>
+                      </a:r>
+                    </a:p>
+                  </a:txBody>
+                  <a:tcPr/>
+                </a:tc>
+                <a:tc>
+                  <a:txBody>
+                    <a:bodyPr/>
+                    <a:lstStyle/>
+                    <a:p>
+                      <a:pPr>
+                        <a:defRPr sz="1300">
+                          <a:solidFill>
+                            <a:srgbClr val="1E293B"/>
+                          </a:solidFill>
+                        </a:defRPr>
+                      </a:pPr>
+                      <a:r>
+                        <a:t>POST /api/events persisted to SQLite</a:t>
+                      </a:r>
+                    </a:p>
+                  </a:txBody>
+                  <a:tcPr/>
+                </a:tc>
+              </a:tr>
+              <a:tr h="731520">
+                <a:tc>
+                  <a:txBody>
+                    <a:bodyPr/>
+                    <a:lstStyle/>
+                    <a:p>
+                      <a:pPr>
+                        <a:defRPr sz="1300">
+                          <a:solidFill>
+                            <a:srgbClr val="1E293B"/>
+                          </a:solidFill>
+                        </a:defRPr>
+                      </a:pPr>
+                      <a:r>
+                        <a:t>Dashboard computations</a:t>
+                      </a:r>
+                    </a:p>
+                  </a:txBody>
+                  <a:tcPr/>
+                </a:tc>
+                <a:tc>
+                  <a:txBody>
+                    <a:bodyPr/>
+                    <a:lstStyle/>
+                    <a:p>
+                      <a:pPr>
+                        <a:defRPr sz="1300">
+                          <a:solidFill>
+                            <a:srgbClr val="1E293B"/>
+                          </a:solidFill>
+                        </a:defRPr>
+                      </a:pPr>
+                      <a:r>
+                        <a:t>Metrics tests</a:t>
+                      </a:r>
+                    </a:p>
+                  </a:txBody>
+                  <a:tcPr/>
+                </a:tc>
+                <a:tc>
+                  <a:txBody>
+                    <a:bodyPr/>
+                    <a:lstStyle/>
+                    <a:p>
+                      <a:pPr>
+                        <a:defRPr sz="1300">
+                          <a:solidFill>
+                            <a:srgbClr val="1E293B"/>
+                          </a:solidFill>
+                        </a:defRPr>
+                      </a:pPr>
+                      <a:r>
+                        <a:t>Funnel/stage/fairness computations verified</a:t>
+                      </a:r>
+                    </a:p>
+                  </a:txBody>
+                  <a:tcPr/>
+                </a:tc>
+              </a:tr>
+              <a:tr h="731520">
+                <a:tc>
+                  <a:txBody>
+                    <a:bodyPr/>
+                    <a:lstStyle/>
+                    <a:p>
+                      <a:pPr>
+                        <a:defRPr sz="1300">
+                          <a:solidFill>
+                            <a:srgbClr val="1E293B"/>
+                          </a:solidFill>
+                        </a:defRPr>
+                      </a:pPr>
+                      <a:r>
+                        <a:t>Balancing rules/simulation</a:t>
+                      </a:r>
+                    </a:p>
+                  </a:txBody>
+                  <a:tcPr/>
+                </a:tc>
+                <a:tc>
+                  <a:txBody>
+                    <a:bodyPr/>
+                    <a:lstStyle/>
+                    <a:p>
+                      <a:pPr>
+                        <a:defRPr sz="1300">
+                          <a:solidFill>
+                            <a:srgbClr val="1E293B"/>
+                          </a:solidFill>
+                        </a:defRPr>
+                      </a:pPr>
+                      <a:r>
+                        <a:t>Balancing tests</a:t>
+                      </a:r>
+                    </a:p>
+                  </a:txBody>
+                  <a:tcPr/>
+                </a:tc>
+                <a:tc>
+                  <a:txBody>
+                    <a:bodyPr/>
+                    <a:lstStyle/>
+                    <a:p>
+                      <a:pPr>
+                        <a:defRPr sz="1300">
+                          <a:solidFill>
+                            <a:srgbClr val="1E293B"/>
+                          </a:solidFill>
+                        </a:defRPr>
+                      </a:pPr>
+                      <a:r>
+                        <a:t>Simulation route returns expected deltas</a:t>
+                      </a:r>
+                    </a:p>
+                  </a:txBody>
+                  <a:tcPr/>
+                </a:tc>
+              </a:tr>
+              <a:tr h="731520">
+                <a:tc>
+                  <a:txBody>
+                    <a:bodyPr/>
+                    <a:lstStyle/>
+                    <a:p>
+                      <a:pPr>
+                        <a:defRPr sz="1300">
+                          <a:solidFill>
+                            <a:srgbClr val="1E293B"/>
+                          </a:solidFill>
+                        </a:defRPr>
+                      </a:pPr>
+                      <a:r>
+                        <a:t>Export endpoints</a:t>
+                      </a:r>
+                    </a:p>
+                  </a:txBody>
+                  <a:tcPr/>
+                </a:tc>
+                <a:tc>
+                  <a:txBody>
+                    <a:bodyPr/>
+                    <a:lstStyle/>
+                    <a:p>
+                      <a:pPr>
+                        <a:defRPr sz="1300">
+                          <a:solidFill>
+                            <a:srgbClr val="1E293B"/>
+                          </a:solidFill>
+                        </a:defRPr>
+                      </a:pPr>
+                      <a:r>
+                        <a:t>API tests</a:t>
+                      </a:r>
+                    </a:p>
+                  </a:txBody>
+                  <a:tcPr/>
+                </a:tc>
+                <a:tc>
+                  <a:txBody>
+                    <a:bodyPr/>
+                    <a:lstStyle/>
+                    <a:p>
+                      <a:pPr>
+                        <a:defRPr sz="1300">
+                          <a:solidFill>
+                            <a:srgbClr val="1E293B"/>
+                          </a:solidFill>
+                        </a:defRPr>
+                      </a:pPr>
+                      <a:r>
+                        <a:t>CSV export route behavior covered</a:t>
+                      </a:r>
+                    </a:p>
+                  </a:txBody>
+                  <a:tcPr/>
+                </a:tc>
+              </a:tr>
+            </a:tbl>
+          </a:graphicData>
+        </a:graphic>
+      </p:graphicFrame>
+      <p:sp>
+        <p:nvSpPr>
+          <p:cNvPr id="4" name="TextBox 3"/>
+          <p:cNvSpPr txBox="1"/>
+          <p:nvPr/>
+        </p:nvSpPr>
+        <p:spPr>
+          <a:xfrm>
+            <a:off x="457200" y="5852160"/>
+            <a:ext cx="10972800" cy="640080"/>
+          </a:xfrm>
+          <a:prstGeom prst="rect">
+            <a:avLst/>
+          </a:prstGeom>
+          <a:noFill/>
+        </p:spPr>
+        <p:txBody>
+          <a:bodyPr wrap="none">
+            <a:spAutoFit/>
+          </a:bodyPr>
           <a:lstStyle/>
           <a:p>
             <a:pPr>
-              <a:defRPr sz="2400">
-                <a:solidFill>
-                  <a:srgbClr val="1E293B"/>
+              <a:defRPr sz="1200" i="1">
+                <a:solidFill>
+                  <a:srgbClr val="2563EB"/>
                 </a:solidFill>
               </a:defRPr>
             </a:pPr>
             <a:r>
-              <a:t>Deployment guide includes local run, production setup, and test commands</a:t>
-            </a:r>
-          </a:p>
-          <a:p>
-            <a:pPr>
-              <a:defRPr sz="2400">
-                <a:solidFill>
-                  <a:srgbClr val="1E293B"/>
-                </a:solidFill>
-              </a:defRPr>
-            </a:pPr>
-            <a:r>
-              <a:t>System remains usable with seeded telemetry data if external services are unavailable</a:t>
-            </a:r>
-          </a:p>
-          <a:p>
-            <a:pPr>
-              <a:defRPr sz="2400">
-                <a:solidFill>
-                  <a:srgbClr val="1E293B"/>
-                </a:solidFill>
-              </a:defRPr>
-            </a:pPr>
-            <a:r>
-              <a:t>Environment-variable based configuration avoids hardcoded secrets</a:t>
-            </a:r>
-          </a:p>
-          <a:p>
-            <a:pPr>
-              <a:defRPr sz="2400">
-                <a:solidFill>
-                  <a:srgbClr val="1E293B"/>
-                </a:solidFill>
-              </a:defRPr>
-            </a:pPr>
-            <a:r>
-              <a:t>Maintainer extension path: add new event type + update schema, ingestion, and metrics</a:t>
+              <a:t>Repository currently contains 15 automated tests across backend test modules.</a:t>
             </a:r>
           </a:p>
         </p:txBody>
@@ -3306,7 +3671,7 @@
               </a:defRPr>
             </a:pPr>
             <a:r>
-              <a:t>10. Evaluation Highlights and Limitations</a:t>
+              <a:t>9. Client Handover and Maintainability</a:t>
             </a:r>
           </a:p>
         </p:txBody>
@@ -3334,7 +3699,7 @@
               </a:defRPr>
             </a:pPr>
             <a:r>
-              <a:t>Detection validity: rules identify known difficult stages in seeded data</a:t>
+              <a:t>Deployment guide includes local run, production setup, and test commands</a:t>
             </a:r>
           </a:p>
           <a:p>
@@ -3346,7 +3711,7 @@
               </a:defRPr>
             </a:pPr>
             <a:r>
-              <a:t>Fairness analysis: segment gaps are measurable and can drive mitigations</a:t>
+              <a:t>System remains usable with seeded telemetry data if external services are unavailable</a:t>
             </a:r>
           </a:p>
           <a:p>
@@ -3358,7 +3723,7 @@
               </a:defRPr>
             </a:pPr>
             <a:r>
-              <a:t>Balancing effectiveness: simulation previews expected progression improvements</a:t>
+              <a:t>Environment-variable based configuration avoids hardcoded secrets</a:t>
             </a:r>
           </a:p>
           <a:p>
@@ -3370,19 +3735,7 @@
               </a:defRPr>
             </a:pPr>
             <a:r>
-              <a:t>Limitation: simulation is lightweight and should be validated with further playtesting</a:t>
-            </a:r>
-          </a:p>
-          <a:p>
-            <a:pPr>
-              <a:defRPr sz="2400">
-                <a:solidFill>
-                  <a:srgbClr val="1E293B"/>
-                </a:solidFill>
-              </a:defRPr>
-            </a:pPr>
-            <a:r>
-              <a:t>Limitation: final manual testing evidence should be packaged in testing_evidence.pdf</a:t>
+              <a:t>Maintainer extension path: add new event type + update schema, ingestion, and metrics</a:t>
             </a:r>
           </a:p>
         </p:txBody>
@@ -3428,6 +3781,128 @@
               </a:defRPr>
             </a:pPr>
             <a:r>
+              <a:t>10. Evaluation Highlights and Limitations</a:t>
+            </a:r>
+          </a:p>
+        </p:txBody>
+      </p:sp>
+      <p:sp>
+        <p:nvSpPr>
+          <p:cNvPr id="3" name="Content Placeholder 2"/>
+          <p:cNvSpPr>
+            <a:spLocks noGrp="1"/>
+          </p:cNvSpPr>
+          <p:nvPr>
+            <p:ph idx="1"/>
+          </p:nvPr>
+        </p:nvSpPr>
+        <p:spPr/>
+        <p:txBody>
+          <a:bodyPr/>
+          <a:lstStyle/>
+          <a:p>
+            <a:pPr>
+              <a:defRPr sz="2400">
+                <a:solidFill>
+                  <a:srgbClr val="1E293B"/>
+                </a:solidFill>
+              </a:defRPr>
+            </a:pPr>
+            <a:r>
+              <a:t>Detection validity: rules identify known difficult stages in seeded data</a:t>
+            </a:r>
+          </a:p>
+          <a:p>
+            <a:pPr>
+              <a:defRPr sz="2400">
+                <a:solidFill>
+                  <a:srgbClr val="1E293B"/>
+                </a:solidFill>
+              </a:defRPr>
+            </a:pPr>
+            <a:r>
+              <a:t>Fairness analysis: segment gaps are measurable and can drive mitigations</a:t>
+            </a:r>
+          </a:p>
+          <a:p>
+            <a:pPr>
+              <a:defRPr sz="2400">
+                <a:solidFill>
+                  <a:srgbClr val="1E293B"/>
+                </a:solidFill>
+              </a:defRPr>
+            </a:pPr>
+            <a:r>
+              <a:t>Balancing effectiveness: simulation previews expected progression improvements</a:t>
+            </a:r>
+          </a:p>
+          <a:p>
+            <a:pPr>
+              <a:defRPr sz="2400">
+                <a:solidFill>
+                  <a:srgbClr val="1E293B"/>
+                </a:solidFill>
+              </a:defRPr>
+            </a:pPr>
+            <a:r>
+              <a:t>Limitation: simulation is lightweight and should be validated with further playtesting</a:t>
+            </a:r>
+          </a:p>
+          <a:p>
+            <a:pPr>
+              <a:defRPr sz="2400">
+                <a:solidFill>
+                  <a:srgbClr val="1E293B"/>
+                </a:solidFill>
+              </a:defRPr>
+            </a:pPr>
+            <a:r>
+              <a:t>Limitation: final manual testing evidence should be packaged in testing_evidence.pdf</a:t>
+            </a:r>
+          </a:p>
+        </p:txBody>
+      </p:sp>
+    </p:spTree>
+  </p:cSld>
+  <p:clrMapOvr>
+    <a:masterClrMapping/>
+  </p:clrMapOvr>
+</p:sld>
+</file>
+
+<file path=ppt/slides/slide13.xml><?xml version="1.0" encoding="utf-8"?>
+<p:sld xmlns:a="http://schemas.openxmlformats.org/drawingml/2006/main" xmlns:p="http://schemas.openxmlformats.org/presentationml/2006/main" xmlns:r="http://schemas.openxmlformats.org/officeDocument/2006/relationships">
+  <p:cSld>
+    <p:spTree>
+      <p:nvGrpSpPr>
+        <p:cNvPr id="1" name=""/>
+        <p:cNvGrpSpPr/>
+        <p:nvPr/>
+      </p:nvGrpSpPr>
+      <p:grpSpPr/>
+      <p:sp>
+        <p:nvSpPr>
+          <p:cNvPr id="2" name="Title 1"/>
+          <p:cNvSpPr>
+            <a:spLocks noGrp="1"/>
+          </p:cNvSpPr>
+          <p:nvPr>
+            <p:ph type="title"/>
+          </p:nvPr>
+        </p:nvSpPr>
+        <p:spPr/>
+        <p:txBody>
+          <a:bodyPr/>
+          <a:lstStyle/>
+          <a:p>
+            <a:pPr>
+              <a:defRPr b="1">
+                <a:solidFill>
+                  <a:srgbClr val="0F172A"/>
+                </a:solidFill>
+              </a:defRPr>
+            </a:pPr>
+            <a:r>
               <a:t>11. Risks, Next Steps, and Closing</a:t>
             </a:r>
           </a:p>
@@ -3585,6 +4060,128 @@
               </a:defRPr>
             </a:pPr>
             <a:r>
+              <a:t>Recap (What You'll See)</a:t>
+            </a:r>
+          </a:p>
+        </p:txBody>
+      </p:sp>
+      <p:sp>
+        <p:nvSpPr>
+          <p:cNvPr id="3" name="Content Placeholder 2"/>
+          <p:cNvSpPr>
+            <a:spLocks noGrp="1"/>
+          </p:cNvSpPr>
+          <p:nvPr>
+            <p:ph idx="1"/>
+          </p:nvPr>
+        </p:nvSpPr>
+        <p:spPr/>
+        <p:txBody>
+          <a:bodyPr/>
+          <a:lstStyle/>
+          <a:p>
+            <a:pPr>
+              <a:defRPr sz="2400">
+                <a:solidFill>
+                  <a:srgbClr val="1E293B"/>
+                </a:solidFill>
+              </a:defRPr>
+            </a:pPr>
+            <a:r>
+              <a:t>Game concept and telemetry-driven balancing problem</a:t>
+            </a:r>
+          </a:p>
+          <a:p>
+            <a:pPr>
+              <a:defRPr sz="2400">
+                <a:solidFill>
+                  <a:srgbClr val="1E293B"/>
+                </a:solidFill>
+              </a:defRPr>
+            </a:pPr>
+            <a:r>
+              <a:t>How we capture, validate, and store telemetry events</a:t>
+            </a:r>
+          </a:p>
+          <a:p>
+            <a:pPr>
+              <a:defRPr sz="2400">
+                <a:solidFill>
+                  <a:srgbClr val="1E293B"/>
+                </a:solidFill>
+              </a:defRPr>
+            </a:pPr>
+            <a:r>
+              <a:t>Dashboard views: funnels, spikes, progression, and fairness indicators</a:t>
+            </a:r>
+          </a:p>
+          <a:p>
+            <a:pPr>
+              <a:defRPr sz="2400">
+                <a:solidFill>
+                  <a:srgbClr val="1E293B"/>
+                </a:solidFill>
+              </a:defRPr>
+            </a:pPr>
+            <a:r>
+              <a:t>Balancing toolkit: rule suggestions, simulation previews, and decision logging</a:t>
+            </a:r>
+          </a:p>
+          <a:p>
+            <a:pPr>
+              <a:defRPr sz="2400">
+                <a:solidFill>
+                  <a:srgbClr val="1E293B"/>
+                </a:solidFill>
+              </a:defRPr>
+            </a:pPr>
+            <a:r>
+              <a:t>Testing, handover pack, and evaluation highlights</a:t>
+            </a:r>
+          </a:p>
+        </p:txBody>
+      </p:sp>
+    </p:spTree>
+  </p:cSld>
+  <p:clrMapOvr>
+    <a:masterClrMapping/>
+  </p:clrMapOvr>
+</p:sld>
+</file>
+
+<file path=ppt/slides/slide3.xml><?xml version="1.0" encoding="utf-8"?>
+<p:sld xmlns:a="http://schemas.openxmlformats.org/drawingml/2006/main" xmlns:p="http://schemas.openxmlformats.org/presentationml/2006/main" xmlns:r="http://schemas.openxmlformats.org/officeDocument/2006/relationships">
+  <p:cSld>
+    <p:spTree>
+      <p:nvGrpSpPr>
+        <p:cNvPr id="1" name=""/>
+        <p:cNvGrpSpPr/>
+        <p:nvPr/>
+      </p:nvGrpSpPr>
+      <p:grpSpPr/>
+      <p:sp>
+        <p:nvSpPr>
+          <p:cNvPr id="2" name="Title 1"/>
+          <p:cNvSpPr>
+            <a:spLocks noGrp="1"/>
+          </p:cNvSpPr>
+          <p:nvPr>
+            <p:ph type="title"/>
+          </p:nvPr>
+        </p:nvSpPr>
+        <p:spPr/>
+        <p:txBody>
+          <a:bodyPr/>
+          <a:lstStyle/>
+          <a:p>
+            <a:pPr>
+              <a:defRPr b="1">
+                <a:solidFill>
+                  <a:srgbClr val="0F172A"/>
+                </a:solidFill>
+              </a:defRPr>
+            </a:pPr>
+            <a:r>
               <a:t>1. What We Delivered in Sprint 2</a:t>
             </a:r>
           </a:p>
@@ -3697,7 +4294,7 @@
 </p:sld>
 </file>
 
-<file path=ppt/slides/slide3.xml><?xml version="1.0" encoding="utf-8"?>
+<file path=ppt/slides/slide4.xml><?xml version="1.0" encoding="utf-8"?>
 <p:sld xmlns:a="http://schemas.openxmlformats.org/drawingml/2006/main" xmlns:p="http://schemas.openxmlformats.org/presentationml/2006/main" xmlns:r="http://schemas.openxmlformats.org/officeDocument/2006/relationships">
   <p:cSld>
     <p:spTree>
@@ -4171,7 +4768,7 @@
 </p:sld>
 </file>
 
-<file path=ppt/slides/slide4.xml><?xml version="1.0" encoding="utf-8"?>
+<file path=ppt/slides/slide5.xml><?xml version="1.0" encoding="utf-8"?>
 <p:sld xmlns:a="http://schemas.openxmlformats.org/drawingml/2006/main" xmlns:p="http://schemas.openxmlformats.org/presentationml/2006/main" xmlns:r="http://schemas.openxmlformats.org/officeDocument/2006/relationships">
   <p:cSld>
     <p:spTree>
@@ -4316,7 +4913,7 @@
 </p:sld>
 </file>
 
-<file path=ppt/slides/slide5.xml><?xml version="1.0" encoding="utf-8"?>
+<file path=ppt/slides/slide6.xml><?xml version="1.0" encoding="utf-8"?>
 <p:sld xmlns:a="http://schemas.openxmlformats.org/drawingml/2006/main" xmlns:p="http://schemas.openxmlformats.org/presentationml/2006/main" xmlns:r="http://schemas.openxmlformats.org/officeDocument/2006/relationships">
   <p:cSld>
     <p:spTree>
@@ -4421,7 +5018,7 @@
 </p:sld>
 </file>
 
-<file path=ppt/slides/slide6.xml><?xml version="1.0" encoding="utf-8"?>
+<file path=ppt/slides/slide7.xml><?xml version="1.0" encoding="utf-8"?>
 <p:sld xmlns:a="http://schemas.openxmlformats.org/drawingml/2006/main" xmlns:p="http://schemas.openxmlformats.org/presentationml/2006/main" xmlns:r="http://schemas.openxmlformats.org/officeDocument/2006/relationships">
   <p:cSld>
     <p:spTree>
@@ -4526,128 +5123,6 @@
 </p:sld>
 </file>
 
-<file path=ppt/slides/slide7.xml><?xml version="1.0" encoding="utf-8"?>
-<p:sld xmlns:a="http://schemas.openxmlformats.org/drawingml/2006/main" xmlns:p="http://schemas.openxmlformats.org/presentationml/2006/main" xmlns:r="http://schemas.openxmlformats.org/officeDocument/2006/relationships">
-  <p:cSld>
-    <p:spTree>
-      <p:nvGrpSpPr>
-        <p:cNvPr id="1" name=""/>
-        <p:cNvGrpSpPr/>
-        <p:nvPr/>
-      </p:nvGrpSpPr>
-      <p:grpSpPr/>
-      <p:sp>
-        <p:nvSpPr>
-          <p:cNvPr id="2" name="Title 1"/>
-          <p:cNvSpPr>
-            <a:spLocks noGrp="1"/>
-          </p:cNvSpPr>
-          <p:nvPr>
-            <p:ph type="title"/>
-          </p:nvPr>
-        </p:nvSpPr>
-        <p:spPr/>
-        <p:txBody>
-          <a:bodyPr/>
-          <a:lstStyle/>
-          <a:p>
-            <a:pPr>
-              <a:defRPr b="1">
-                <a:solidFill>
-                  <a:srgbClr val="0F172A"/>
-                </a:solidFill>
-              </a:defRPr>
-            </a:pPr>
-            <a:r>
-              <a:t>6. Dashboard Insights for Designers</a:t>
-            </a:r>
-          </a:p>
-        </p:txBody>
-      </p:sp>
-      <p:sp>
-        <p:nvSpPr>
-          <p:cNvPr id="3" name="Content Placeholder 2"/>
-          <p:cNvSpPr>
-            <a:spLocks noGrp="1"/>
-          </p:cNvSpPr>
-          <p:nvPr>
-            <p:ph idx="1"/>
-          </p:nvPr>
-        </p:nvSpPr>
-        <p:spPr/>
-        <p:txBody>
-          <a:bodyPr/>
-          <a:lstStyle/>
-          <a:p>
-            <a:pPr>
-              <a:defRPr sz="2400">
-                <a:solidFill>
-                  <a:srgbClr val="1E293B"/>
-                </a:solidFill>
-              </a:defRPr>
-            </a:pPr>
-            <a:r>
-              <a:t>Funnel analytics: stage-by-stage completion and drop-off rates</a:t>
-            </a:r>
-          </a:p>
-          <a:p>
-            <a:pPr>
-              <a:defRPr sz="2400">
-                <a:solidFill>
-                  <a:srgbClr val="1E293B"/>
-                </a:solidFill>
-              </a:defRPr>
-            </a:pPr>
-            <a:r>
-              <a:t>Difficulty spike detection: high fail/time pressure stages are highlighted</a:t>
-            </a:r>
-          </a:p>
-          <a:p>
-            <a:pPr>
-              <a:defRPr sz="2400">
-                <a:solidFill>
-                  <a:srgbClr val="1E293B"/>
-                </a:solidFill>
-              </a:defRPr>
-            </a:pPr>
-            <a:r>
-              <a:t>Progression curves: completion time and token economy trends by stage</a:t>
-            </a:r>
-          </a:p>
-          <a:p>
-            <a:pPr>
-              <a:defRPr sz="2400">
-                <a:solidFill>
-                  <a:srgbClr val="1E293B"/>
-                </a:solidFill>
-              </a:defRPr>
-            </a:pPr>
-            <a:r>
-              <a:t>Fairness indicators: segment comparison (e.g., fast vs slow players)</a:t>
-            </a:r>
-          </a:p>
-          <a:p>
-            <a:pPr>
-              <a:defRPr sz="2400">
-                <a:solidFill>
-                  <a:srgbClr val="1E293B"/>
-                </a:solidFill>
-              </a:defRPr>
-            </a:pPr>
-            <a:r>
-              <a:t>Config comparison mode for easy vs balanced vs hard</a:t>
-            </a:r>
-          </a:p>
-        </p:txBody>
-      </p:sp>
-    </p:spTree>
-  </p:cSld>
-  <p:clrMapOvr>
-    <a:masterClrMapping/>
-  </p:clrMapOvr>
-</p:sld>
-</file>
-
 <file path=ppt/slides/slide8.xml><?xml version="1.0" encoding="utf-8"?>
 <p:sld xmlns:a="http://schemas.openxmlformats.org/drawingml/2006/main" xmlns:p="http://schemas.openxmlformats.org/presentationml/2006/main" xmlns:r="http://schemas.openxmlformats.org/officeDocument/2006/relationships">
   <p:cSld>
@@ -4681,7 +5156,7 @@
               </a:defRPr>
             </a:pPr>
             <a:r>
-              <a:t>7. Balancing Toolkit Demo Scenario</a:t>
+              <a:t>6. Dashboard Insights for Designers</a:t>
             </a:r>
           </a:p>
         </p:txBody>
@@ -4709,7 +5184,7 @@
               </a:defRPr>
             </a:pPr>
             <a:r>
-              <a:t>Rule triggers flag problematic stages (e.g., fail rate too high, fairness gap too large)</a:t>
+              <a:t>Funnel analytics: stage-by-stage completion and drop-off rates</a:t>
             </a:r>
           </a:p>
           <a:p>
@@ -4721,7 +5196,7 @@
               </a:defRPr>
             </a:pPr>
             <a:r>
-              <a:t>Designer edits parameters (timer, move limits, helper costs, penalties, rewards)</a:t>
+              <a:t>Difficulty spike detection: high fail/time pressure stages are highlighted</a:t>
             </a:r>
           </a:p>
           <a:p>
@@ -4733,7 +5208,7 @@
               </a:defRPr>
             </a:pPr>
             <a:r>
-              <a:t>Simulation estimates before/after completion, failure, and quit rates</a:t>
+              <a:t>Progression curves: completion time and token economy trends by stage</a:t>
             </a:r>
           </a:p>
           <a:p>
@@ -4745,42 +5220,19 @@
               </a:defRPr>
             </a:pPr>
             <a:r>
-              <a:t>Decision log captures change, rationale, and evidence link for auditability</a:t>
-            </a:r>
-          </a:p>
-        </p:txBody>
-      </p:sp>
-      <p:sp>
-        <p:nvSpPr>
-          <p:cNvPr id="4" name="TextBox 3"/>
-          <p:cNvSpPr txBox="1"/>
-          <p:nvPr/>
-        </p:nvSpPr>
-        <p:spPr>
-          <a:xfrm>
-            <a:off x="640080" y="5943600"/>
-            <a:ext cx="10972800" cy="548640"/>
-          </a:xfrm>
-          <a:prstGeom prst="rect">
-            <a:avLst/>
-          </a:prstGeom>
-          <a:noFill/>
-        </p:spPr>
-        <p:txBody>
-          <a:bodyPr wrap="none">
-            <a:spAutoFit/>
-          </a:bodyPr>
-          <a:lstStyle/>
-          <a:p>
-            <a:pPr algn="l">
-              <a:defRPr sz="1300" i="1">
-                <a:solidFill>
-                  <a:srgbClr val="2563EB"/>
+              <a:t>Fairness indicators: segment comparison (e.g., fast vs slow players)</a:t>
+            </a:r>
+          </a:p>
+          <a:p>
+            <a:pPr>
+              <a:defRPr sz="2400">
+                <a:solidFill>
+                  <a:srgbClr val="1E293B"/>
                 </a:solidFill>
               </a:defRPr>
             </a:pPr>
             <a:r>
-              <a:t>Demo example: +10 seconds on Stage 2 increased predicted completion rate.</a:t>
+              <a:t>Config comparison mode for easy vs balanced vs hard</a:t>
             </a:r>
           </a:p>
         </p:txBody>
@@ -4826,404 +5278,75 @@
               </a:defRPr>
             </a:pPr>
             <a:r>
-              <a:t>8. Testing and Quality Evidence</a:t>
-            </a:r>
-          </a:p>
-        </p:txBody>
-      </p:sp>
-      <p:graphicFrame>
-        <p:nvGraphicFramePr>
-          <p:cNvPr id="3" name="Table 2"/>
-          <p:cNvGraphicFramePr>
-            <a:graphicFrameLocks noGrp="1"/>
-          </p:cNvGraphicFramePr>
-          <p:nvPr/>
-        </p:nvGraphicFramePr>
-        <p:xfrm>
-          <a:off x="365760" y="1280160"/>
-          <a:ext cx="11430000" cy="4389120"/>
-        </p:xfrm>
-        <a:graphic>
-          <a:graphicData uri="http://schemas.openxmlformats.org/drawingml/2006/table">
-            <a:tbl>
-              <a:tblPr firstRow="1" bandRow="1">
-                <a:tableStyleId>{5C22544A-7EE6-4342-B048-85BDC9FD1C3A}</a:tableStyleId>
-              </a:tblPr>
-              <a:tblGrid>
-                <a:gridCol w="3810000"/>
-                <a:gridCol w="3810000"/>
-                <a:gridCol w="3810000"/>
-              </a:tblGrid>
-              <a:tr h="731520">
-                <a:tc>
-                  <a:txBody>
-                    <a:bodyPr/>
-                    <a:lstStyle/>
-                    <a:p>
-                      <a:pPr>
-                        <a:defRPr b="1" sz="1400">
-                          <a:solidFill>
-                            <a:srgbClr val="FFFFFF"/>
-                          </a:solidFill>
-                        </a:defRPr>
-                      </a:pPr>
-                      <a:r>
-                        <a:t>Area</a:t>
-                      </a:r>
-                    </a:p>
-                  </a:txBody>
-                  <a:tcPr>
-                    <a:solidFill>
-                      <a:srgbClr val="2563EB"/>
-                    </a:solidFill>
-                  </a:tcPr>
-                </a:tc>
-                <a:tc>
-                  <a:txBody>
-                    <a:bodyPr/>
-                    <a:lstStyle/>
-                    <a:p>
-                      <a:pPr>
-                        <a:defRPr b="1" sz="1400">
-                          <a:solidFill>
-                            <a:srgbClr val="FFFFFF"/>
-                          </a:solidFill>
-                        </a:defRPr>
-                      </a:pPr>
-                      <a:r>
-                        <a:t>Automated coverage</a:t>
-                      </a:r>
-                    </a:p>
-                  </a:txBody>
-                  <a:tcPr>
-                    <a:solidFill>
-                      <a:srgbClr val="2563EB"/>
-                    </a:solidFill>
-                  </a:tcPr>
-                </a:tc>
-                <a:tc>
-                  <a:txBody>
-                    <a:bodyPr/>
-                    <a:lstStyle/>
-                    <a:p>
-                      <a:pPr>
-                        <a:defRPr b="1" sz="1400">
-                          <a:solidFill>
-                            <a:srgbClr val="FFFFFF"/>
-                          </a:solidFill>
-                        </a:defRPr>
-                      </a:pPr>
-                      <a:r>
-                        <a:t>Current evidence</a:t>
-                      </a:r>
-                    </a:p>
-                  </a:txBody>
-                  <a:tcPr>
-                    <a:solidFill>
-                      <a:srgbClr val="2563EB"/>
-                    </a:solidFill>
-                  </a:tcPr>
-                </a:tc>
-              </a:tr>
-              <a:tr h="731520">
-                <a:tc>
-                  <a:txBody>
-                    <a:bodyPr/>
-                    <a:lstStyle/>
-                    <a:p>
-                      <a:pPr>
-                        <a:defRPr sz="1300">
-                          <a:solidFill>
-                            <a:srgbClr val="1E293B"/>
-                          </a:solidFill>
-                        </a:defRPr>
-                      </a:pPr>
-                      <a:r>
-                        <a:t>Telemetry validation</a:t>
-                      </a:r>
-                    </a:p>
-                  </a:txBody>
-                  <a:tcPr/>
-                </a:tc>
-                <a:tc>
-                  <a:txBody>
-                    <a:bodyPr/>
-                    <a:lstStyle/>
-                    <a:p>
-                      <a:pPr>
-                        <a:defRPr sz="1300">
-                          <a:solidFill>
-                            <a:srgbClr val="1E293B"/>
-                          </a:solidFill>
-                        </a:defRPr>
-                      </a:pPr>
-                      <a:r>
-                        <a:t>Unit tests</a:t>
-                      </a:r>
-                    </a:p>
-                  </a:txBody>
-                  <a:tcPr/>
-                </a:tc>
-                <a:tc>
-                  <a:txBody>
-                    <a:bodyPr/>
-                    <a:lstStyle/>
-                    <a:p>
-                      <a:pPr>
-                        <a:defRPr sz="1300">
-                          <a:solidFill>
-                            <a:srgbClr val="1E293B"/>
-                          </a:solidFill>
-                        </a:defRPr>
-                      </a:pPr>
-                      <a:r>
-                        <a:t>Event required fields and types validated</a:t>
-                      </a:r>
-                    </a:p>
-                  </a:txBody>
-                  <a:tcPr/>
-                </a:tc>
-              </a:tr>
-              <a:tr h="731520">
-                <a:tc>
-                  <a:txBody>
-                    <a:bodyPr/>
-                    <a:lstStyle/>
-                    <a:p>
-                      <a:pPr>
-                        <a:defRPr sz="1300">
-                          <a:solidFill>
-                            <a:srgbClr val="1E293B"/>
-                          </a:solidFill>
-                        </a:defRPr>
-                      </a:pPr>
-                      <a:r>
-                        <a:t>Data ingestion/storage</a:t>
-                      </a:r>
-                    </a:p>
-                  </a:txBody>
-                  <a:tcPr/>
-                </a:tc>
-                <a:tc>
-                  <a:txBody>
-                    <a:bodyPr/>
-                    <a:lstStyle/>
-                    <a:p>
-                      <a:pPr>
-                        <a:defRPr sz="1300">
-                          <a:solidFill>
-                            <a:srgbClr val="1E293B"/>
-                          </a:solidFill>
-                        </a:defRPr>
-                      </a:pPr>
-                      <a:r>
-                        <a:t>Integration tests</a:t>
-                      </a:r>
-                    </a:p>
-                  </a:txBody>
-                  <a:tcPr/>
-                </a:tc>
-                <a:tc>
-                  <a:txBody>
-                    <a:bodyPr/>
-                    <a:lstStyle/>
-                    <a:p>
-                      <a:pPr>
-                        <a:defRPr sz="1300">
-                          <a:solidFill>
-                            <a:srgbClr val="1E293B"/>
-                          </a:solidFill>
-                        </a:defRPr>
-                      </a:pPr>
-                      <a:r>
-                        <a:t>POST /api/events persisted to SQLite</a:t>
-                      </a:r>
-                    </a:p>
-                  </a:txBody>
-                  <a:tcPr/>
-                </a:tc>
-              </a:tr>
-              <a:tr h="731520">
-                <a:tc>
-                  <a:txBody>
-                    <a:bodyPr/>
-                    <a:lstStyle/>
-                    <a:p>
-                      <a:pPr>
-                        <a:defRPr sz="1300">
-                          <a:solidFill>
-                            <a:srgbClr val="1E293B"/>
-                          </a:solidFill>
-                        </a:defRPr>
-                      </a:pPr>
-                      <a:r>
-                        <a:t>Dashboard computations</a:t>
-                      </a:r>
-                    </a:p>
-                  </a:txBody>
-                  <a:tcPr/>
-                </a:tc>
-                <a:tc>
-                  <a:txBody>
-                    <a:bodyPr/>
-                    <a:lstStyle/>
-                    <a:p>
-                      <a:pPr>
-                        <a:defRPr sz="1300">
-                          <a:solidFill>
-                            <a:srgbClr val="1E293B"/>
-                          </a:solidFill>
-                        </a:defRPr>
-                      </a:pPr>
-                      <a:r>
-                        <a:t>Metrics tests</a:t>
-                      </a:r>
-                    </a:p>
-                  </a:txBody>
-                  <a:tcPr/>
-                </a:tc>
-                <a:tc>
-                  <a:txBody>
-                    <a:bodyPr/>
-                    <a:lstStyle/>
-                    <a:p>
-                      <a:pPr>
-                        <a:defRPr sz="1300">
-                          <a:solidFill>
-                            <a:srgbClr val="1E293B"/>
-                          </a:solidFill>
-                        </a:defRPr>
-                      </a:pPr>
-                      <a:r>
-                        <a:t>Funnel/stage/fairness computations verified</a:t>
-                      </a:r>
-                    </a:p>
-                  </a:txBody>
-                  <a:tcPr/>
-                </a:tc>
-              </a:tr>
-              <a:tr h="731520">
-                <a:tc>
-                  <a:txBody>
-                    <a:bodyPr/>
-                    <a:lstStyle/>
-                    <a:p>
-                      <a:pPr>
-                        <a:defRPr sz="1300">
-                          <a:solidFill>
-                            <a:srgbClr val="1E293B"/>
-                          </a:solidFill>
-                        </a:defRPr>
-                      </a:pPr>
-                      <a:r>
-                        <a:t>Balancing rules/simulation</a:t>
-                      </a:r>
-                    </a:p>
-                  </a:txBody>
-                  <a:tcPr/>
-                </a:tc>
-                <a:tc>
-                  <a:txBody>
-                    <a:bodyPr/>
-                    <a:lstStyle/>
-                    <a:p>
-                      <a:pPr>
-                        <a:defRPr sz="1300">
-                          <a:solidFill>
-                            <a:srgbClr val="1E293B"/>
-                          </a:solidFill>
-                        </a:defRPr>
-                      </a:pPr>
-                      <a:r>
-                        <a:t>Balancing tests</a:t>
-                      </a:r>
-                    </a:p>
-                  </a:txBody>
-                  <a:tcPr/>
-                </a:tc>
-                <a:tc>
-                  <a:txBody>
-                    <a:bodyPr/>
-                    <a:lstStyle/>
-                    <a:p>
-                      <a:pPr>
-                        <a:defRPr sz="1300">
-                          <a:solidFill>
-                            <a:srgbClr val="1E293B"/>
-                          </a:solidFill>
-                        </a:defRPr>
-                      </a:pPr>
-                      <a:r>
-                        <a:t>Simulation route returns expected deltas</a:t>
-                      </a:r>
-                    </a:p>
-                  </a:txBody>
-                  <a:tcPr/>
-                </a:tc>
-              </a:tr>
-              <a:tr h="731520">
-                <a:tc>
-                  <a:txBody>
-                    <a:bodyPr/>
-                    <a:lstStyle/>
-                    <a:p>
-                      <a:pPr>
-                        <a:defRPr sz="1300">
-                          <a:solidFill>
-                            <a:srgbClr val="1E293B"/>
-                          </a:solidFill>
-                        </a:defRPr>
-                      </a:pPr>
-                      <a:r>
-                        <a:t>Export endpoints</a:t>
-                      </a:r>
-                    </a:p>
-                  </a:txBody>
-                  <a:tcPr/>
-                </a:tc>
-                <a:tc>
-                  <a:txBody>
-                    <a:bodyPr/>
-                    <a:lstStyle/>
-                    <a:p>
-                      <a:pPr>
-                        <a:defRPr sz="1300">
-                          <a:solidFill>
-                            <a:srgbClr val="1E293B"/>
-                          </a:solidFill>
-                        </a:defRPr>
-                      </a:pPr>
-                      <a:r>
-                        <a:t>API tests</a:t>
-                      </a:r>
-                    </a:p>
-                  </a:txBody>
-                  <a:tcPr/>
-                </a:tc>
-                <a:tc>
-                  <a:txBody>
-                    <a:bodyPr/>
-                    <a:lstStyle/>
-                    <a:p>
-                      <a:pPr>
-                        <a:defRPr sz="1300">
-                          <a:solidFill>
-                            <a:srgbClr val="1E293B"/>
-                          </a:solidFill>
-                        </a:defRPr>
-                      </a:pPr>
-                      <a:r>
-                        <a:t>CSV export route behavior covered</a:t>
-                      </a:r>
-                    </a:p>
-                  </a:txBody>
-                  <a:tcPr/>
-                </a:tc>
-              </a:tr>
-            </a:tbl>
-          </a:graphicData>
-        </a:graphic>
-      </p:graphicFrame>
+              <a:t>7. Balancing Toolkit Demo Scenario</a:t>
+            </a:r>
+          </a:p>
+        </p:txBody>
+      </p:sp>
+      <p:sp>
+        <p:nvSpPr>
+          <p:cNvPr id="3" name="Content Placeholder 2"/>
+          <p:cNvSpPr>
+            <a:spLocks noGrp="1"/>
+          </p:cNvSpPr>
+          <p:nvPr>
+            <p:ph idx="1"/>
+          </p:nvPr>
+        </p:nvSpPr>
+        <p:spPr/>
+        <p:txBody>
+          <a:bodyPr/>
+          <a:lstStyle/>
+          <a:p>
+            <a:pPr>
+              <a:defRPr sz="2400">
+                <a:solidFill>
+                  <a:srgbClr val="1E293B"/>
+                </a:solidFill>
+              </a:defRPr>
+            </a:pPr>
+            <a:r>
+              <a:t>Rule triggers flag problematic stages (e.g., fail rate too high, fairness gap too large)</a:t>
+            </a:r>
+          </a:p>
+          <a:p>
+            <a:pPr>
+              <a:defRPr sz="2400">
+                <a:solidFill>
+                  <a:srgbClr val="1E293B"/>
+                </a:solidFill>
+              </a:defRPr>
+            </a:pPr>
+            <a:r>
+              <a:t>Designer edits parameters (timer, move limits, helper costs, penalties, rewards)</a:t>
+            </a:r>
+          </a:p>
+          <a:p>
+            <a:pPr>
+              <a:defRPr sz="2400">
+                <a:solidFill>
+                  <a:srgbClr val="1E293B"/>
+                </a:solidFill>
+              </a:defRPr>
+            </a:pPr>
+            <a:r>
+              <a:t>Simulation estimates before/after completion, failure, and quit rates</a:t>
+            </a:r>
+          </a:p>
+          <a:p>
+            <a:pPr>
+              <a:defRPr sz="2400">
+                <a:solidFill>
+                  <a:srgbClr val="1E293B"/>
+                </a:solidFill>
+              </a:defRPr>
+            </a:pPr>
+            <a:r>
+              <a:t>Decision log captures change, rationale, and evidence link for auditability</a:t>
+            </a:r>
+          </a:p>
+        </p:txBody>
+      </p:sp>
       <p:sp>
         <p:nvSpPr>
           <p:cNvPr id="4" name="TextBox 3"/>
@@ -5232,8 +5355,8 @@
         </p:nvSpPr>
         <p:spPr>
           <a:xfrm>
-            <a:off x="457200" y="5852160"/>
-            <a:ext cx="10972800" cy="640080"/>
+            <a:off x="640080" y="5943600"/>
+            <a:ext cx="10972800" cy="548640"/>
           </a:xfrm>
           <a:prstGeom prst="rect">
             <a:avLst/>
@@ -5246,15 +5369,15 @@
           </a:bodyPr>
           <a:lstStyle/>
           <a:p>
-            <a:pPr>
-              <a:defRPr sz="1200" i="1">
+            <a:pPr algn="l">
+              <a:defRPr sz="1300" i="1">
                 <a:solidFill>
                   <a:srgbClr val="2563EB"/>
                 </a:solidFill>
               </a:defRPr>
             </a:pPr>
             <a:r>
-              <a:t>Repository currently contains 15 automated tests across backend test modules.</a:t>
+              <a:t>Demo example: +10 seconds on Stage 2 increased predicted completion rate.</a:t>
             </a:r>
           </a:p>
         </p:txBody>

</xml_diff>